<commit_message>
docs(slides): update intro deck
Co-Authored-By: Claude Opus 5.5 <noreply@anthropic.com>
</commit_message>
<xml_diff>
--- a/00-fundamentos/slides/Introducción al Aprendizaje No Supervisado - UDEM.pptx
+++ b/00-fundamentos/slides/Introducción al Aprendizaje No Supervisado - UDEM.pptx
@@ -18,8 +18,9 @@
     <p:sldId id="269" r:id="rId12"/>
     <p:sldId id="266" r:id="rId13"/>
     <p:sldId id="270" r:id="rId14"/>
-    <p:sldId id="267" r:id="rId15"/>
-    <p:sldId id="268" r:id="rId16"/>
+    <p:sldId id="271" r:id="rId15"/>
+    <p:sldId id="267" r:id="rId16"/>
+    <p:sldId id="268" r:id="rId17"/>
   </p:sldIdLst>
   <p:sldSz cx="9144000" cy="5143500" type="screen16x9"/>
   <p:notesSz cx="6858000" cy="9144000"/>
@@ -4309,7 +4310,7 @@
           <a:noFill/>
         </p:spPr>
         <p:txBody>
-          <a:bodyPr wrap="square" lIns="0" rIns="0" tIns="0" bIns="0" anchor="t">
+          <a:bodyPr wrap="square" lIns="0" tIns="0" rIns="0" bIns="0" anchor="t">
             <a:spAutoFit/>
           </a:bodyPr>
           <a:lstStyle/>
@@ -4363,7 +4364,7 @@
           </a:fontRef>
         </p:style>
         <p:txBody>
-          <a:bodyPr rtlCol="0" anchor="ctr" lIns="0" rIns="0" tIns="0" bIns="0"/>
+          <a:bodyPr lIns="0" tIns="0" rIns="0" bIns="0" rtlCol="0" anchor="ctr"/>
           <a:lstStyle/>
           <a:p>
             <a:pPr algn="ctr"/>
@@ -4396,7 +4397,7 @@
           <a:noFill/>
         </p:spPr>
         <p:txBody>
-          <a:bodyPr wrap="square" lIns="0" rIns="0" tIns="0" bIns="0" anchor="t">
+          <a:bodyPr wrap="square" lIns="0" tIns="0" rIns="0" bIns="0" anchor="t">
             <a:spAutoFit/>
           </a:bodyPr>
           <a:lstStyle/>
@@ -4464,7 +4465,9 @@
         <p:txBody>
           <a:bodyPr rtlCol="0" anchor="ctr"/>
           <a:lstStyle/>
-          <a:p/>
+          <a:p>
+            <a:endParaRPr/>
+          </a:p>
         </p:txBody>
       </p:sp>
       <p:sp>
@@ -4503,7 +4506,7 @@
           </a:fontRef>
         </p:style>
         <p:txBody>
-          <a:bodyPr rtlCol="0" anchor="ctr" lIns="0" rIns="0" tIns="0" bIns="0"/>
+          <a:bodyPr lIns="0" tIns="0" rIns="0" bIns="0" rtlCol="0" anchor="ctr"/>
           <a:lstStyle/>
           <a:p>
             <a:pPr algn="ctr"/>
@@ -4536,7 +4539,7 @@
           <a:noFill/>
         </p:spPr>
         <p:txBody>
-          <a:bodyPr wrap="square" lIns="0" rIns="0" tIns="0" bIns="0" anchor="t">
+          <a:bodyPr wrap="square" lIns="0" tIns="0" rIns="0" bIns="0" anchor="t">
             <a:spAutoFit/>
           </a:bodyPr>
           <a:lstStyle/>
@@ -4604,7 +4607,9 @@
         <p:txBody>
           <a:bodyPr rtlCol="0" anchor="ctr"/>
           <a:lstStyle/>
-          <a:p/>
+          <a:p>
+            <a:endParaRPr/>
+          </a:p>
         </p:txBody>
       </p:sp>
       <p:sp>
@@ -4643,7 +4648,7 @@
           </a:fontRef>
         </p:style>
         <p:txBody>
-          <a:bodyPr rtlCol="0" anchor="ctr" lIns="0" rIns="0" tIns="0" bIns="0"/>
+          <a:bodyPr lIns="0" tIns="0" rIns="0" bIns="0" rtlCol="0" anchor="ctr"/>
           <a:lstStyle/>
           <a:p>
             <a:pPr algn="ctr"/>
@@ -4676,7 +4681,7 @@
           <a:noFill/>
         </p:spPr>
         <p:txBody>
-          <a:bodyPr wrap="square" lIns="0" rIns="0" tIns="0" bIns="0" anchor="t">
+          <a:bodyPr wrap="square" lIns="0" tIns="0" rIns="0" bIns="0" anchor="t">
             <a:spAutoFit/>
           </a:bodyPr>
           <a:lstStyle/>
@@ -4744,7 +4749,9 @@
         <p:txBody>
           <a:bodyPr rtlCol="0" anchor="ctr"/>
           <a:lstStyle/>
-          <a:p/>
+          <a:p>
+            <a:endParaRPr/>
+          </a:p>
         </p:txBody>
       </p:sp>
       <p:sp>
@@ -4783,7 +4790,7 @@
           </a:fontRef>
         </p:style>
         <p:txBody>
-          <a:bodyPr rtlCol="0" anchor="ctr" lIns="0" rIns="0" tIns="0" bIns="0"/>
+          <a:bodyPr lIns="0" tIns="0" rIns="0" bIns="0" rtlCol="0" anchor="ctr"/>
           <a:lstStyle/>
           <a:p>
             <a:pPr algn="ctr"/>
@@ -4816,7 +4823,7 @@
           <a:noFill/>
         </p:spPr>
         <p:txBody>
-          <a:bodyPr wrap="square" lIns="0" rIns="0" tIns="0" bIns="0" anchor="t">
+          <a:bodyPr wrap="square" lIns="0" tIns="0" rIns="0" bIns="0" anchor="t">
             <a:spAutoFit/>
           </a:bodyPr>
           <a:lstStyle/>
@@ -4886,7 +4893,9 @@
         <p:txBody>
           <a:bodyPr rtlCol="0" anchor="ctr"/>
           <a:lstStyle/>
-          <a:p/>
+          <a:p>
+            <a:endParaRPr/>
+          </a:p>
         </p:txBody>
       </p:sp>
       <p:sp>
@@ -4906,7 +4915,7 @@
           <a:noFill/>
         </p:spPr>
         <p:txBody>
-          <a:bodyPr wrap="square" lIns="0" rIns="0" tIns="0" bIns="0" anchor="ctr">
+          <a:bodyPr wrap="square" lIns="0" tIns="0" rIns="0" bIns="0" anchor="ctr">
             <a:spAutoFit/>
           </a:bodyPr>
           <a:lstStyle/>
@@ -5231,7 +5240,7 @@
           <a:noFill/>
         </p:spPr>
         <p:txBody>
-          <a:bodyPr wrap="square" lIns="0" rIns="0" tIns="0" bIns="0" anchor="t">
+          <a:bodyPr wrap="square" lIns="0" tIns="0" rIns="0" bIns="0" anchor="t">
             <a:spAutoFit/>
           </a:bodyPr>
           <a:lstStyle/>
@@ -5285,7 +5294,7 @@
           </a:fontRef>
         </p:style>
         <p:txBody>
-          <a:bodyPr rtlCol="0" anchor="ctr" lIns="0" rIns="0" tIns="0" bIns="0"/>
+          <a:bodyPr lIns="0" tIns="0" rIns="0" bIns="0" rtlCol="0" anchor="ctr"/>
           <a:lstStyle/>
           <a:p>
             <a:pPr algn="ctr"/>
@@ -5318,7 +5327,7 @@
           <a:noFill/>
         </p:spPr>
         <p:txBody>
-          <a:bodyPr wrap="square" lIns="0" rIns="0" tIns="0" bIns="0" anchor="t">
+          <a:bodyPr wrap="square" lIns="0" tIns="0" rIns="0" bIns="0" anchor="t">
             <a:spAutoFit/>
           </a:bodyPr>
           <a:lstStyle/>
@@ -5386,7 +5395,9 @@
         <p:txBody>
           <a:bodyPr rtlCol="0" anchor="ctr"/>
           <a:lstStyle/>
-          <a:p/>
+          <a:p>
+            <a:endParaRPr/>
+          </a:p>
         </p:txBody>
       </p:sp>
       <p:sp>
@@ -5425,7 +5436,7 @@
           </a:fontRef>
         </p:style>
         <p:txBody>
-          <a:bodyPr rtlCol="0" anchor="ctr" lIns="0" rIns="0" tIns="0" bIns="0"/>
+          <a:bodyPr lIns="0" tIns="0" rIns="0" bIns="0" rtlCol="0" anchor="ctr"/>
           <a:lstStyle/>
           <a:p>
             <a:pPr algn="ctr"/>
@@ -5458,7 +5469,7 @@
           <a:noFill/>
         </p:spPr>
         <p:txBody>
-          <a:bodyPr wrap="square" lIns="0" rIns="0" tIns="0" bIns="0" anchor="t">
+          <a:bodyPr wrap="square" lIns="0" tIns="0" rIns="0" bIns="0" anchor="t">
             <a:spAutoFit/>
           </a:bodyPr>
           <a:lstStyle/>
@@ -5526,7 +5537,9 @@
         <p:txBody>
           <a:bodyPr rtlCol="0" anchor="ctr"/>
           <a:lstStyle/>
-          <a:p/>
+          <a:p>
+            <a:endParaRPr/>
+          </a:p>
         </p:txBody>
       </p:sp>
       <p:sp>
@@ -5565,7 +5578,7 @@
           </a:fontRef>
         </p:style>
         <p:txBody>
-          <a:bodyPr rtlCol="0" anchor="ctr" lIns="0" rIns="0" tIns="0" bIns="0"/>
+          <a:bodyPr lIns="0" tIns="0" rIns="0" bIns="0" rtlCol="0" anchor="ctr"/>
           <a:lstStyle/>
           <a:p>
             <a:pPr algn="ctr"/>
@@ -5598,7 +5611,7 @@
           <a:noFill/>
         </p:spPr>
         <p:txBody>
-          <a:bodyPr wrap="square" lIns="0" rIns="0" tIns="0" bIns="0" anchor="t">
+          <a:bodyPr wrap="square" lIns="0" tIns="0" rIns="0" bIns="0" anchor="t">
             <a:spAutoFit/>
           </a:bodyPr>
           <a:lstStyle/>
@@ -5666,7 +5679,9 @@
         <p:txBody>
           <a:bodyPr rtlCol="0" anchor="ctr"/>
           <a:lstStyle/>
-          <a:p/>
+          <a:p>
+            <a:endParaRPr/>
+          </a:p>
         </p:txBody>
       </p:sp>
       <p:sp>
@@ -5705,7 +5720,7 @@
           </a:fontRef>
         </p:style>
         <p:txBody>
-          <a:bodyPr rtlCol="0" anchor="ctr" lIns="0" rIns="0" tIns="0" bIns="0"/>
+          <a:bodyPr lIns="0" tIns="0" rIns="0" bIns="0" rtlCol="0" anchor="ctr"/>
           <a:lstStyle/>
           <a:p>
             <a:pPr algn="ctr"/>
@@ -5738,7 +5753,7 @@
           <a:noFill/>
         </p:spPr>
         <p:txBody>
-          <a:bodyPr wrap="square" lIns="0" rIns="0" tIns="0" bIns="0" anchor="t">
+          <a:bodyPr wrap="square" lIns="0" tIns="0" rIns="0" bIns="0" anchor="t">
             <a:spAutoFit/>
           </a:bodyPr>
           <a:lstStyle/>
@@ -5808,7 +5823,9 @@
         <p:txBody>
           <a:bodyPr rtlCol="0" anchor="ctr"/>
           <a:lstStyle/>
-          <a:p/>
+          <a:p>
+            <a:endParaRPr/>
+          </a:p>
         </p:txBody>
       </p:sp>
       <p:sp>
@@ -5828,7 +5845,7 @@
           <a:noFill/>
         </p:spPr>
         <p:txBody>
-          <a:bodyPr wrap="square" lIns="0" rIns="0" tIns="0" bIns="0" anchor="ctr">
+          <a:bodyPr wrap="square" lIns="0" tIns="0" rIns="0" bIns="0" anchor="ctr">
             <a:spAutoFit/>
           </a:bodyPr>
           <a:lstStyle/>
@@ -6176,7 +6193,7 @@
           <a:noFill/>
         </p:spPr>
         <p:txBody>
-          <a:bodyPr wrap="square" lIns="0" rIns="0" tIns="0" bIns="0" anchor="t">
+          <a:bodyPr wrap="square" lIns="0" tIns="0" rIns="0" bIns="0" anchor="t">
             <a:spAutoFit/>
           </a:bodyPr>
           <a:lstStyle/>
@@ -6230,7 +6247,7 @@
           </a:fontRef>
         </p:style>
         <p:txBody>
-          <a:bodyPr rtlCol="0" anchor="ctr" lIns="0" rIns="0" tIns="0" bIns="0"/>
+          <a:bodyPr lIns="0" tIns="0" rIns="0" bIns="0" rtlCol="0" anchor="ctr"/>
           <a:lstStyle/>
           <a:p>
             <a:pPr algn="ctr"/>
@@ -6263,7 +6280,7 @@
           <a:noFill/>
         </p:spPr>
         <p:txBody>
-          <a:bodyPr wrap="square" lIns="0" rIns="0" tIns="0" bIns="0" anchor="t">
+          <a:bodyPr wrap="square" lIns="0" tIns="0" rIns="0" bIns="0" anchor="t">
             <a:spAutoFit/>
           </a:bodyPr>
           <a:lstStyle/>
@@ -6331,7 +6348,9 @@
         <p:txBody>
           <a:bodyPr rtlCol="0" anchor="ctr"/>
           <a:lstStyle/>
-          <a:p/>
+          <a:p>
+            <a:endParaRPr/>
+          </a:p>
         </p:txBody>
       </p:sp>
       <p:sp>
@@ -6370,7 +6389,7 @@
           </a:fontRef>
         </p:style>
         <p:txBody>
-          <a:bodyPr rtlCol="0" anchor="ctr" lIns="0" rIns="0" tIns="0" bIns="0"/>
+          <a:bodyPr lIns="0" tIns="0" rIns="0" bIns="0" rtlCol="0" anchor="ctr"/>
           <a:lstStyle/>
           <a:p>
             <a:pPr algn="ctr"/>
@@ -6403,7 +6422,7 @@
           <a:noFill/>
         </p:spPr>
         <p:txBody>
-          <a:bodyPr wrap="square" lIns="0" rIns="0" tIns="0" bIns="0" anchor="t">
+          <a:bodyPr wrap="square" lIns="0" tIns="0" rIns="0" bIns="0" anchor="t">
             <a:spAutoFit/>
           </a:bodyPr>
           <a:lstStyle/>
@@ -6471,7 +6490,9 @@
         <p:txBody>
           <a:bodyPr rtlCol="0" anchor="ctr"/>
           <a:lstStyle/>
-          <a:p/>
+          <a:p>
+            <a:endParaRPr/>
+          </a:p>
         </p:txBody>
       </p:sp>
       <p:sp>
@@ -6510,7 +6531,7 @@
           </a:fontRef>
         </p:style>
         <p:txBody>
-          <a:bodyPr rtlCol="0" anchor="ctr" lIns="0" rIns="0" tIns="0" bIns="0"/>
+          <a:bodyPr lIns="0" tIns="0" rIns="0" bIns="0" rtlCol="0" anchor="ctr"/>
           <a:lstStyle/>
           <a:p>
             <a:pPr algn="ctr"/>
@@ -6543,7 +6564,7 @@
           <a:noFill/>
         </p:spPr>
         <p:txBody>
-          <a:bodyPr wrap="square" lIns="0" rIns="0" tIns="0" bIns="0" anchor="t">
+          <a:bodyPr wrap="square" lIns="0" tIns="0" rIns="0" bIns="0" anchor="t">
             <a:spAutoFit/>
           </a:bodyPr>
           <a:lstStyle/>
@@ -6611,7 +6632,9 @@
         <p:txBody>
           <a:bodyPr rtlCol="0" anchor="ctr"/>
           <a:lstStyle/>
-          <a:p/>
+          <a:p>
+            <a:endParaRPr/>
+          </a:p>
         </p:txBody>
       </p:sp>
       <p:sp>
@@ -6650,7 +6673,7 @@
           </a:fontRef>
         </p:style>
         <p:txBody>
-          <a:bodyPr rtlCol="0" anchor="ctr" lIns="0" rIns="0" tIns="0" bIns="0"/>
+          <a:bodyPr lIns="0" tIns="0" rIns="0" bIns="0" rtlCol="0" anchor="ctr"/>
           <a:lstStyle/>
           <a:p>
             <a:pPr algn="ctr"/>
@@ -6683,7 +6706,7 @@
           <a:noFill/>
         </p:spPr>
         <p:txBody>
-          <a:bodyPr wrap="square" lIns="0" rIns="0" tIns="0" bIns="0" anchor="t">
+          <a:bodyPr wrap="square" lIns="0" tIns="0" rIns="0" bIns="0" anchor="t">
             <a:spAutoFit/>
           </a:bodyPr>
           <a:lstStyle/>
@@ -6753,7 +6776,9 @@
         <p:txBody>
           <a:bodyPr rtlCol="0" anchor="ctr"/>
           <a:lstStyle/>
-          <a:p/>
+          <a:p>
+            <a:endParaRPr/>
+          </a:p>
         </p:txBody>
       </p:sp>
       <p:sp>
@@ -6773,7 +6798,7 @@
           <a:noFill/>
         </p:spPr>
         <p:txBody>
-          <a:bodyPr wrap="square" lIns="0" rIns="0" tIns="0" bIns="0" anchor="ctr">
+          <a:bodyPr wrap="square" lIns="0" tIns="0" rIns="0" bIns="0" anchor="ctr">
             <a:spAutoFit/>
           </a:bodyPr>
           <a:lstStyle/>
@@ -6823,6 +6848,441 @@
 </file>
 
 <file path=ppt/slides/slide14.xml><?xml version="1.0" encoding="utf-8"?>
+<p:sld xmlns:a="http://schemas.openxmlformats.org/drawingml/2006/main" xmlns:r="http://schemas.openxmlformats.org/officeDocument/2006/relationships" xmlns:p="http://schemas.openxmlformats.org/presentationml/2006/main">
+  <p:cSld>
+    <p:spTree>
+      <p:nvGrpSpPr>
+        <p:cNvPr id="1" name="">
+          <a:extLst>
+            <a:ext uri="{FF2B5EF4-FFF2-40B4-BE49-F238E27FC236}">
+              <a16:creationId xmlns:a16="http://schemas.microsoft.com/office/drawing/2014/main" id="{E825B686-6D8C-BB28-A206-871CB9604132}"/>
+            </a:ext>
+          </a:extLst>
+        </p:cNvPr>
+        <p:cNvGrpSpPr/>
+        <p:nvPr/>
+      </p:nvGrpSpPr>
+      <p:grpSpPr>
+        <a:xfrm>
+          <a:off x="0" y="0"/>
+          <a:ext cx="0" cy="0"/>
+          <a:chOff x="0" y="0"/>
+          <a:chExt cx="0" cy="0"/>
+        </a:xfrm>
+      </p:grpSpPr>
+      <p:sp>
+        <p:nvSpPr>
+          <p:cNvPr id="2" name="Rectangle 1">
+            <a:extLst>
+              <a:ext uri="{FF2B5EF4-FFF2-40B4-BE49-F238E27FC236}">
+                <a16:creationId xmlns:a16="http://schemas.microsoft.com/office/drawing/2014/main" id="{8EB35FDF-58D9-2D9F-8141-22BD87AAF26E}"/>
+              </a:ext>
+            </a:extLst>
+          </p:cNvPr>
+          <p:cNvSpPr/>
+          <p:nvPr/>
+        </p:nvSpPr>
+        <p:spPr>
+          <a:xfrm>
+            <a:off x="0" y="0"/>
+            <a:ext cx="9144000" cy="914400"/>
+          </a:xfrm>
+          <a:prstGeom prst="rect">
+            <a:avLst/>
+          </a:prstGeom>
+          <a:solidFill>
+            <a:srgbClr val="1A1A1A"/>
+          </a:solidFill>
+          <a:ln>
+            <a:noFill/>
+          </a:ln>
+        </p:spPr>
+        <p:style>
+          <a:lnRef idx="1">
+            <a:schemeClr val="accent1"/>
+          </a:lnRef>
+          <a:fillRef idx="3">
+            <a:schemeClr val="accent1"/>
+          </a:fillRef>
+          <a:effectRef idx="2">
+            <a:schemeClr val="accent1"/>
+          </a:effectRef>
+          <a:fontRef idx="minor">
+            <a:schemeClr val="lt1"/>
+          </a:fontRef>
+        </p:style>
+        <p:txBody>
+          <a:bodyPr rtlCol="0" anchor="ctr"/>
+          <a:lstStyle/>
+          <a:p>
+            <a:endParaRPr/>
+          </a:p>
+        </p:txBody>
+      </p:sp>
+      <p:sp>
+        <p:nvSpPr>
+          <p:cNvPr id="3" name="Rectangle 2">
+            <a:extLst>
+              <a:ext uri="{FF2B5EF4-FFF2-40B4-BE49-F238E27FC236}">
+                <a16:creationId xmlns:a16="http://schemas.microsoft.com/office/drawing/2014/main" id="{7C0B45B5-CF4C-BC77-A430-4CA9E2F9CB2E}"/>
+              </a:ext>
+            </a:extLst>
+          </p:cNvPr>
+          <p:cNvSpPr/>
+          <p:nvPr/>
+        </p:nvSpPr>
+        <p:spPr>
+          <a:xfrm>
+            <a:off x="0" y="868680"/>
+            <a:ext cx="9144000" cy="45720"/>
+          </a:xfrm>
+          <a:prstGeom prst="rect">
+            <a:avLst/>
+          </a:prstGeom>
+          <a:solidFill>
+            <a:srgbClr val="FFF500"/>
+          </a:solidFill>
+          <a:ln>
+            <a:noFill/>
+          </a:ln>
+        </p:spPr>
+        <p:style>
+          <a:lnRef idx="1">
+            <a:schemeClr val="accent1"/>
+          </a:lnRef>
+          <a:fillRef idx="3">
+            <a:schemeClr val="accent1"/>
+          </a:fillRef>
+          <a:effectRef idx="2">
+            <a:schemeClr val="accent1"/>
+          </a:effectRef>
+          <a:fontRef idx="minor">
+            <a:schemeClr val="lt1"/>
+          </a:fontRef>
+        </p:style>
+        <p:txBody>
+          <a:bodyPr rtlCol="0" anchor="ctr"/>
+          <a:lstStyle/>
+          <a:p>
+            <a:endParaRPr/>
+          </a:p>
+        </p:txBody>
+      </p:sp>
+      <p:sp>
+        <p:nvSpPr>
+          <p:cNvPr id="4" name="TextBox 3">
+            <a:extLst>
+              <a:ext uri="{FF2B5EF4-FFF2-40B4-BE49-F238E27FC236}">
+                <a16:creationId xmlns:a16="http://schemas.microsoft.com/office/drawing/2014/main" id="{2077CF77-64BC-C9B0-8B3B-0A2B7C30DDAE}"/>
+              </a:ext>
+            </a:extLst>
+          </p:cNvPr>
+          <p:cNvSpPr txBox="1"/>
+          <p:nvPr/>
+        </p:nvSpPr>
+        <p:spPr>
+          <a:xfrm>
+            <a:off x="548640" y="137160"/>
+            <a:ext cx="8046720" cy="640080"/>
+          </a:xfrm>
+          <a:prstGeom prst="rect">
+            <a:avLst/>
+          </a:prstGeom>
+          <a:noFill/>
+        </p:spPr>
+        <p:txBody>
+          <a:bodyPr wrap="square" lIns="0" tIns="0" rIns="0" bIns="0" anchor="ctr">
+            <a:spAutoFit/>
+          </a:bodyPr>
+          <a:lstStyle/>
+          <a:p>
+            <a:pPr algn="l"/>
+            <a:r>
+              <a:rPr sz="2800" b="1" i="0">
+                <a:solidFill>
+                  <a:srgbClr val="FFFFFF"/>
+                </a:solidFill>
+                <a:latin typeface="Arial"/>
+              </a:rPr>
+              <a:t>Caso de estudio: minería (Caterpillar)</a:t>
+            </a:r>
+          </a:p>
+        </p:txBody>
+      </p:sp>
+      <p:sp>
+        <p:nvSpPr>
+          <p:cNvPr id="5" name="Rectangle 4">
+            <a:extLst>
+              <a:ext uri="{FF2B5EF4-FFF2-40B4-BE49-F238E27FC236}">
+                <a16:creationId xmlns:a16="http://schemas.microsoft.com/office/drawing/2014/main" id="{30196DE1-7B6A-AFDB-AED4-2FB94374E216}"/>
+              </a:ext>
+            </a:extLst>
+          </p:cNvPr>
+          <p:cNvSpPr/>
+          <p:nvPr/>
+        </p:nvSpPr>
+        <p:spPr>
+          <a:xfrm>
+            <a:off x="0" y="4873752"/>
+            <a:ext cx="9144000" cy="274320"/>
+          </a:xfrm>
+          <a:prstGeom prst="rect">
+            <a:avLst/>
+          </a:prstGeom>
+          <a:solidFill>
+            <a:srgbClr val="1A1A1A"/>
+          </a:solidFill>
+          <a:ln>
+            <a:noFill/>
+          </a:ln>
+        </p:spPr>
+        <p:style>
+          <a:lnRef idx="1">
+            <a:schemeClr val="accent1"/>
+          </a:lnRef>
+          <a:fillRef idx="3">
+            <a:schemeClr val="accent1"/>
+          </a:fillRef>
+          <a:effectRef idx="2">
+            <a:schemeClr val="accent1"/>
+          </a:effectRef>
+          <a:fontRef idx="minor">
+            <a:schemeClr val="lt1"/>
+          </a:fontRef>
+        </p:style>
+        <p:txBody>
+          <a:bodyPr rtlCol="0" anchor="ctr"/>
+          <a:lstStyle/>
+          <a:p>
+            <a:endParaRPr/>
+          </a:p>
+        </p:txBody>
+      </p:sp>
+      <p:sp>
+        <p:nvSpPr>
+          <p:cNvPr id="6" name="TextBox 5">
+            <a:extLst>
+              <a:ext uri="{FF2B5EF4-FFF2-40B4-BE49-F238E27FC236}">
+                <a16:creationId xmlns:a16="http://schemas.microsoft.com/office/drawing/2014/main" id="{A8419360-62AC-C835-B918-F75076C18B46}"/>
+              </a:ext>
+            </a:extLst>
+          </p:cNvPr>
+          <p:cNvSpPr txBox="1"/>
+          <p:nvPr/>
+        </p:nvSpPr>
+        <p:spPr>
+          <a:xfrm>
+            <a:off x="457200" y="4892040"/>
+            <a:ext cx="8229600" cy="228600"/>
+          </a:xfrm>
+          <a:prstGeom prst="rect">
+            <a:avLst/>
+          </a:prstGeom>
+          <a:noFill/>
+        </p:spPr>
+        <p:txBody>
+          <a:bodyPr wrap="square" lIns="0" tIns="0" rIns="0" bIns="0" anchor="ctr">
+            <a:spAutoFit/>
+          </a:bodyPr>
+          <a:lstStyle/>
+          <a:p>
+            <a:pPr algn="l"/>
+            <a:r>
+              <a:rPr sz="800" b="0" i="0">
+                <a:solidFill>
+                  <a:srgbClr val="666666"/>
+                </a:solidFill>
+                <a:latin typeface="Calibri"/>
+              </a:rPr>
+              <a:t>UDEM  |  Modelos de Analítica Predictiva  |  Jorge A. Ramírez García, M.Eng.</a:t>
+            </a:r>
+          </a:p>
+        </p:txBody>
+      </p:sp>
+      <p:sp>
+        <p:nvSpPr>
+          <p:cNvPr id="21" name="Rounded Rectangle 20">
+            <a:extLst>
+              <a:ext uri="{FF2B5EF4-FFF2-40B4-BE49-F238E27FC236}">
+                <a16:creationId xmlns:a16="http://schemas.microsoft.com/office/drawing/2014/main" id="{E124D3E0-6751-1204-B9D4-39FF42DF54B7}"/>
+              </a:ext>
+            </a:extLst>
+          </p:cNvPr>
+          <p:cNvSpPr/>
+          <p:nvPr/>
+        </p:nvSpPr>
+        <p:spPr>
+          <a:xfrm>
+            <a:off x="457200" y="3977639"/>
+            <a:ext cx="8229600" cy="640080"/>
+          </a:xfrm>
+          <a:prstGeom prst="roundRect">
+            <a:avLst>
+              <a:gd name="adj" fmla="val 3571"/>
+            </a:avLst>
+          </a:prstGeom>
+          <a:solidFill>
+            <a:srgbClr val="E8F5E9"/>
+          </a:solidFill>
+          <a:ln>
+            <a:noFill/>
+          </a:ln>
+        </p:spPr>
+        <p:style>
+          <a:lnRef idx="1">
+            <a:schemeClr val="accent1"/>
+          </a:lnRef>
+          <a:fillRef idx="3">
+            <a:schemeClr val="accent1"/>
+          </a:fillRef>
+          <a:effectRef idx="2">
+            <a:schemeClr val="accent1"/>
+          </a:effectRef>
+          <a:fontRef idx="minor">
+            <a:schemeClr val="lt1"/>
+          </a:fontRef>
+        </p:style>
+        <p:txBody>
+          <a:bodyPr rtlCol="0" anchor="ctr"/>
+          <a:lstStyle/>
+          <a:p>
+            <a:endParaRPr/>
+          </a:p>
+        </p:txBody>
+      </p:sp>
+      <p:sp>
+        <p:nvSpPr>
+          <p:cNvPr id="22" name="TextBox 21">
+            <a:extLst>
+              <a:ext uri="{FF2B5EF4-FFF2-40B4-BE49-F238E27FC236}">
+                <a16:creationId xmlns:a16="http://schemas.microsoft.com/office/drawing/2014/main" id="{7802007B-F394-72F2-19EE-D19B4B86747E}"/>
+              </a:ext>
+            </a:extLst>
+          </p:cNvPr>
+          <p:cNvSpPr txBox="1"/>
+          <p:nvPr/>
+        </p:nvSpPr>
+        <p:spPr>
+          <a:xfrm>
+            <a:off x="594360" y="4050791"/>
+            <a:ext cx="7955279" cy="493775"/>
+          </a:xfrm>
+          <a:prstGeom prst="rect">
+            <a:avLst/>
+          </a:prstGeom>
+          <a:noFill/>
+        </p:spPr>
+        <p:txBody>
+          <a:bodyPr wrap="square" lIns="0" tIns="0" rIns="0" bIns="0" anchor="ctr">
+            <a:spAutoFit/>
+          </a:bodyPr>
+          <a:lstStyle/>
+          <a:p>
+            <a:pPr algn="l"/>
+            <a:r>
+              <a:rPr sz="1200" b="0" i="0">
+                <a:solidFill>
+                  <a:srgbClr val="2E7D32"/>
+                </a:solidFill>
+                <a:latin typeface="Calibri"/>
+              </a:rPr>
+              <a:t>Resultado: tramos con </a:t>
+            </a:r>
+            <a:r>
+              <a:rPr sz="1200" b="1" i="0">
+                <a:solidFill>
+                  <a:srgbClr val="2E7D32"/>
+                </a:solidFill>
+                <a:latin typeface="Calibri"/>
+              </a:rPr>
+              <a:t>forma libre</a:t>
+            </a:r>
+            <a:r>
+              <a:rPr sz="1200" b="0" i="0">
+                <a:solidFill>
+                  <a:srgbClr val="2E7D32"/>
+                </a:solidFill>
+                <a:latin typeface="Calibri"/>
+              </a:rPr>
+              <a:t> y sin decir cuántos hay. Ahí se compara a todas las máquinas en las mismas condiciones.</a:t>
+            </a:r>
+          </a:p>
+        </p:txBody>
+      </p:sp>
+      <p:pic>
+        <p:nvPicPr>
+          <p:cNvPr id="26" name="Imagen 25">
+            <a:extLst>
+              <a:ext uri="{FF2B5EF4-FFF2-40B4-BE49-F238E27FC236}">
+                <a16:creationId xmlns:a16="http://schemas.microsoft.com/office/drawing/2014/main" id="{0A35F721-793B-2069-2BE5-EFA5F17290B8}"/>
+              </a:ext>
+            </a:extLst>
+          </p:cNvPr>
+          <p:cNvPicPr>
+            <a:picLocks noChangeAspect="1"/>
+          </p:cNvPicPr>
+          <p:nvPr/>
+        </p:nvPicPr>
+        <p:blipFill>
+          <a:blip r:embed="rId2"/>
+          <a:stretch>
+            <a:fillRect/>
+          </a:stretch>
+        </p:blipFill>
+        <p:spPr>
+          <a:xfrm>
+            <a:off x="822850" y="1378458"/>
+            <a:ext cx="2616200" cy="2324100"/>
+          </a:xfrm>
+          <a:prstGeom prst="rect">
+            <a:avLst/>
+          </a:prstGeom>
+        </p:spPr>
+      </p:pic>
+      <p:pic>
+        <p:nvPicPr>
+          <p:cNvPr id="27" name="Imagen 26">
+            <a:extLst>
+              <a:ext uri="{FF2B5EF4-FFF2-40B4-BE49-F238E27FC236}">
+                <a16:creationId xmlns:a16="http://schemas.microsoft.com/office/drawing/2014/main" id="{0F2F6977-F1AF-A00D-58B5-0176A7EB657F}"/>
+              </a:ext>
+            </a:extLst>
+          </p:cNvPr>
+          <p:cNvPicPr>
+            <a:picLocks noChangeAspect="1"/>
+          </p:cNvPicPr>
+          <p:nvPr/>
+        </p:nvPicPr>
+        <p:blipFill>
+          <a:blip r:embed="rId3"/>
+          <a:stretch>
+            <a:fillRect/>
+          </a:stretch>
+        </p:blipFill>
+        <p:spPr>
+          <a:xfrm>
+            <a:off x="3774550" y="2108708"/>
+            <a:ext cx="4546600" cy="863600"/>
+          </a:xfrm>
+          <a:prstGeom prst="rect">
+            <a:avLst/>
+          </a:prstGeom>
+        </p:spPr>
+      </p:pic>
+    </p:spTree>
+    <p:extLst>
+      <p:ext uri="{BB962C8B-B14F-4D97-AF65-F5344CB8AC3E}">
+        <p14:creationId xmlns:p14="http://schemas.microsoft.com/office/powerpoint/2010/main" val="3881868956"/>
+      </p:ext>
+    </p:extLst>
+  </p:cSld>
+  <p:clrMapOvr>
+    <a:masterClrMapping/>
+  </p:clrMapOvr>
+</p:sld>
+</file>
+
+<file path=ppt/slides/slide15.xml><?xml version="1.0" encoding="utf-8"?>
 <p:sld xmlns:a="http://schemas.openxmlformats.org/drawingml/2006/main" xmlns:r="http://schemas.openxmlformats.org/officeDocument/2006/relationships" xmlns:p="http://schemas.openxmlformats.org/presentationml/2006/main">
   <p:cSld>
     <p:bg>
@@ -7335,7 +7795,7 @@
                     <a:lstStyle/>
                     <a:p>
                       <a:r>
-                        <a:rPr sz="1100" b="0" i="0">
+                        <a:rPr sz="1100" b="0" i="0" dirty="0">
                           <a:solidFill>
                             <a:srgbClr val="1A1A1A"/>
                           </a:solidFill>
@@ -7430,13 +7890,49 @@
                     <a:lstStyle/>
                     <a:p>
                       <a:r>
-                        <a:rPr sz="1100" b="0" i="0">
+                        <a:rPr sz="1100" b="0" i="0" dirty="0">
                           <a:solidFill>
                             <a:srgbClr val="1A1A1A"/>
                           </a:solidFill>
                           <a:latin typeface="Calibri"/>
                         </a:rPr>
-                        <a:t>Mall + entregas GPS en Monterrey</a:t>
+                        <a:t>Mall + </a:t>
+                      </a:r>
+                      <a:r>
+                        <a:rPr sz="1100" b="0" i="0" dirty="0" err="1">
+                          <a:solidFill>
+                            <a:srgbClr val="1A1A1A"/>
+                          </a:solidFill>
+                          <a:latin typeface="Calibri"/>
+                        </a:rPr>
+                        <a:t>entregas</a:t>
+                      </a:r>
+                      <a:r>
+                        <a:rPr sz="1100" b="0" i="0" dirty="0">
+                          <a:solidFill>
+                            <a:srgbClr val="1A1A1A"/>
+                          </a:solidFill>
+                          <a:latin typeface="Calibri"/>
+                        </a:rPr>
+                        <a:t> GPS </a:t>
+                      </a:r>
+                      <a:r>
+                        <a:rPr sz="1100" b="0" i="0" dirty="0" err="1">
+                          <a:solidFill>
+                            <a:srgbClr val="1A1A1A"/>
+                          </a:solidFill>
+                          <a:latin typeface="Calibri"/>
+                        </a:rPr>
+                        <a:t>en</a:t>
+                      </a:r>
+                      <a:r>
+                        <a:rPr sz="1100" b="0" i="0" dirty="0">
+                          <a:solidFill>
+                            <a:srgbClr val="1A1A1A"/>
+                          </a:solidFill>
+                          <a:latin typeface="Calibri"/>
+                        </a:rPr>
+                        <a:t> Monterrey</a:t>
                       </a:r>
                     </a:p>
                   </a:txBody>
@@ -7452,13 +7948,139 @@
                     <a:lstStyle/>
                     <a:p>
                       <a:r>
-                        <a:rPr sz="1100" b="0" i="0">
+                        <a:rPr sz="1100" b="0" i="0" dirty="0">
                           <a:solidFill>
                             <a:srgbClr val="1A1A1A"/>
                           </a:solidFill>
                           <a:latin typeface="Calibri"/>
                         </a:rPr>
-                        <a:t>¿Qué clientes no encajan? ¿Dónde poner centros de distribución?</a:t>
+                        <a:t>¿</a:t>
+                      </a:r>
+                      <a:r>
+                        <a:rPr sz="1100" b="0" i="0" dirty="0" err="1">
+                          <a:solidFill>
+                            <a:srgbClr val="1A1A1A"/>
+                          </a:solidFill>
+                          <a:latin typeface="Calibri"/>
+                        </a:rPr>
+                        <a:t>Qué</a:t>
+                      </a:r>
+                      <a:r>
+                        <a:rPr sz="1100" b="0" i="0" dirty="0">
+                          <a:solidFill>
+                            <a:srgbClr val="1A1A1A"/>
+                          </a:solidFill>
+                          <a:latin typeface="Calibri"/>
+                        </a:rPr>
+                        <a:t> </a:t>
+                      </a:r>
+                      <a:r>
+                        <a:rPr sz="1100" b="0" i="0" dirty="0" err="1">
+                          <a:solidFill>
+                            <a:srgbClr val="1A1A1A"/>
+                          </a:solidFill>
+                          <a:latin typeface="Calibri"/>
+                        </a:rPr>
+                        <a:t>clientes</a:t>
+                      </a:r>
+                      <a:r>
+                        <a:rPr sz="1100" b="0" i="0" dirty="0">
+                          <a:solidFill>
+                            <a:srgbClr val="1A1A1A"/>
+                          </a:solidFill>
+                          <a:latin typeface="Calibri"/>
+                        </a:rPr>
+                        <a:t> no </a:t>
+                      </a:r>
+                      <a:r>
+                        <a:rPr sz="1100" b="0" i="0" dirty="0" err="1">
+                          <a:solidFill>
+                            <a:srgbClr val="1A1A1A"/>
+                          </a:solidFill>
+                          <a:latin typeface="Calibri"/>
+                        </a:rPr>
+                        <a:t>encajan</a:t>
+                      </a:r>
+                      <a:r>
+                        <a:rPr sz="1100" b="0" i="0" dirty="0">
+                          <a:solidFill>
+                            <a:srgbClr val="1A1A1A"/>
+                          </a:solidFill>
+                          <a:latin typeface="Calibri"/>
+                        </a:rPr>
+                        <a:t>? ¿</a:t>
+                      </a:r>
+                      <a:r>
+                        <a:rPr sz="1100" b="0" i="0" dirty="0" err="1">
+                          <a:solidFill>
+                            <a:srgbClr val="1A1A1A"/>
+                          </a:solidFill>
+                          <a:latin typeface="Calibri"/>
+                        </a:rPr>
+                        <a:t>Dónde</a:t>
+                      </a:r>
+                      <a:r>
+                        <a:rPr sz="1100" b="0" i="0" dirty="0">
+                          <a:solidFill>
+                            <a:srgbClr val="1A1A1A"/>
+                          </a:solidFill>
+                          <a:latin typeface="Calibri"/>
+                        </a:rPr>
+                        <a:t> </a:t>
+                      </a:r>
+                      <a:r>
+                        <a:rPr sz="1100" b="0" i="0" dirty="0" err="1">
+                          <a:solidFill>
+                            <a:srgbClr val="1A1A1A"/>
+                          </a:solidFill>
+                          <a:latin typeface="Calibri"/>
+                        </a:rPr>
+                        <a:t>poner</a:t>
+                      </a:r>
+                      <a:r>
+                        <a:rPr sz="1100" b="0" i="0" dirty="0">
+                          <a:solidFill>
+                            <a:srgbClr val="1A1A1A"/>
+                          </a:solidFill>
+                          <a:latin typeface="Calibri"/>
+                        </a:rPr>
+                        <a:t> </a:t>
+                      </a:r>
+                      <a:r>
+                        <a:rPr sz="1100" b="0" i="0" dirty="0" err="1">
+                          <a:solidFill>
+                            <a:srgbClr val="1A1A1A"/>
+                          </a:solidFill>
+                          <a:latin typeface="Calibri"/>
+                        </a:rPr>
+                        <a:t>centros</a:t>
+                      </a:r>
+                      <a:r>
+                        <a:rPr sz="1100" b="0" i="0" dirty="0">
+                          <a:solidFill>
+                            <a:srgbClr val="1A1A1A"/>
+                          </a:solidFill>
+                          <a:latin typeface="Calibri"/>
+                        </a:rPr>
+                        <a:t> de </a:t>
+                      </a:r>
+                      <a:r>
+                        <a:rPr sz="1100" b="0" i="0" dirty="0" err="1">
+                          <a:solidFill>
+                            <a:srgbClr val="1A1A1A"/>
+                          </a:solidFill>
+                          <a:latin typeface="Calibri"/>
+                        </a:rPr>
+                        <a:t>distribución</a:t>
+                      </a:r>
+                      <a:r>
+                        <a:rPr sz="1100" b="0" i="0" dirty="0">
+                          <a:solidFill>
+                            <a:srgbClr val="1A1A1A"/>
+                          </a:solidFill>
+                          <a:latin typeface="Calibri"/>
+                        </a:rPr>
+                        <a:t>?</a:t>
                       </a:r>
                     </a:p>
                   </a:txBody>
@@ -7547,13 +8169,121 @@
                     <a:lstStyle/>
                     <a:p>
                       <a:r>
-                        <a:rPr sz="1100" b="0" i="0">
+                        <a:rPr sz="1100" b="0" i="0" dirty="0">
                           <a:solidFill>
                             <a:srgbClr val="1A1A1A"/>
                           </a:solidFill>
                           <a:latin typeface="Calibri"/>
                         </a:rPr>
-                        <a:t>¿Cuántas medidas químicas necesitamos para distinguir los vinos?</a:t>
+                        <a:t>¿</a:t>
+                      </a:r>
+                      <a:r>
+                        <a:rPr sz="1100" b="0" i="0" dirty="0" err="1">
+                          <a:solidFill>
+                            <a:srgbClr val="1A1A1A"/>
+                          </a:solidFill>
+                          <a:latin typeface="Calibri"/>
+                        </a:rPr>
+                        <a:t>Cuántas</a:t>
+                      </a:r>
+                      <a:r>
+                        <a:rPr sz="1100" b="0" i="0" dirty="0">
+                          <a:solidFill>
+                            <a:srgbClr val="1A1A1A"/>
+                          </a:solidFill>
+                          <a:latin typeface="Calibri"/>
+                        </a:rPr>
+                        <a:t> </a:t>
+                      </a:r>
+                      <a:r>
+                        <a:rPr sz="1100" b="0" i="0" dirty="0" err="1">
+                          <a:solidFill>
+                            <a:srgbClr val="1A1A1A"/>
+                          </a:solidFill>
+                          <a:latin typeface="Calibri"/>
+                        </a:rPr>
+                        <a:t>medidas</a:t>
+                      </a:r>
+                      <a:r>
+                        <a:rPr sz="1100" b="0" i="0" dirty="0">
+                          <a:solidFill>
+                            <a:srgbClr val="1A1A1A"/>
+                          </a:solidFill>
+                          <a:latin typeface="Calibri"/>
+                        </a:rPr>
+                        <a:t> </a:t>
+                      </a:r>
+                      <a:r>
+                        <a:rPr sz="1100" b="0" i="0" dirty="0" err="1">
+                          <a:solidFill>
+                            <a:srgbClr val="1A1A1A"/>
+                          </a:solidFill>
+                          <a:latin typeface="Calibri"/>
+                        </a:rPr>
+                        <a:t>químicas</a:t>
+                      </a:r>
+                      <a:r>
+                        <a:rPr sz="1100" b="0" i="0" dirty="0">
+                          <a:solidFill>
+                            <a:srgbClr val="1A1A1A"/>
+                          </a:solidFill>
+                          <a:latin typeface="Calibri"/>
+                        </a:rPr>
+                        <a:t> </a:t>
+                      </a:r>
+                      <a:r>
+                        <a:rPr sz="1100" b="0" i="0" dirty="0" err="1">
+                          <a:solidFill>
+                            <a:srgbClr val="1A1A1A"/>
+                          </a:solidFill>
+                          <a:latin typeface="Calibri"/>
+                        </a:rPr>
+                        <a:t>necesitamos</a:t>
+                      </a:r>
+                      <a:r>
+                        <a:rPr sz="1100" b="0" i="0" dirty="0">
+                          <a:solidFill>
+                            <a:srgbClr val="1A1A1A"/>
+                          </a:solidFill>
+                          <a:latin typeface="Calibri"/>
+                        </a:rPr>
+                        <a:t> para </a:t>
+                      </a:r>
+                      <a:r>
+                        <a:rPr sz="1100" b="0" i="0" dirty="0" err="1">
+                          <a:solidFill>
+                            <a:srgbClr val="1A1A1A"/>
+                          </a:solidFill>
+                          <a:latin typeface="Calibri"/>
+                        </a:rPr>
+                        <a:t>distinguir</a:t>
+                      </a:r>
+                      <a:r>
+                        <a:rPr sz="1100" b="0" i="0" dirty="0">
+                          <a:solidFill>
+                            <a:srgbClr val="1A1A1A"/>
+                          </a:solidFill>
+                          <a:latin typeface="Calibri"/>
+                        </a:rPr>
+                        <a:t> </a:t>
+                      </a:r>
+                      <a:r>
+                        <a:rPr sz="1100" b="0" i="0" dirty="0" err="1">
+                          <a:solidFill>
+                            <a:srgbClr val="1A1A1A"/>
+                          </a:solidFill>
+                          <a:latin typeface="Calibri"/>
+                        </a:rPr>
+                        <a:t>los</a:t>
+                      </a:r>
+                      <a:r>
+                        <a:rPr sz="1100" b="0" i="0" dirty="0">
+                          <a:solidFill>
+                            <a:srgbClr val="1A1A1A"/>
+                          </a:solidFill>
+                          <a:latin typeface="Calibri"/>
+                        </a:rPr>
+                        <a:t> vinos?</a:t>
                       </a:r>
                     </a:p>
                   </a:txBody>
@@ -7642,13 +8372,103 @@
                     <a:lstStyle/>
                     <a:p>
                       <a:r>
-                        <a:rPr sz="1100" b="0" i="0">
+                        <a:rPr sz="1100" b="0" i="0" dirty="0">
                           <a:solidFill>
                             <a:srgbClr val="1A1A1A"/>
                           </a:solidFill>
                           <a:latin typeface="Calibri"/>
                         </a:rPr>
-                        <a:t>¿Cómo organizar a los clientes? (escalado → PCA → K-Means vs DBSCAN)</a:t>
+                        <a:t>¿</a:t>
+                      </a:r>
+                      <a:r>
+                        <a:rPr sz="1100" b="0" i="0" dirty="0" err="1">
+                          <a:solidFill>
+                            <a:srgbClr val="1A1A1A"/>
+                          </a:solidFill>
+                          <a:latin typeface="Calibri"/>
+                        </a:rPr>
+                        <a:t>Cómo</a:t>
+                      </a:r>
+                      <a:r>
+                        <a:rPr sz="1100" b="0" i="0" dirty="0">
+                          <a:solidFill>
+                            <a:srgbClr val="1A1A1A"/>
+                          </a:solidFill>
+                          <a:latin typeface="Calibri"/>
+                        </a:rPr>
+                        <a:t> </a:t>
+                      </a:r>
+                      <a:r>
+                        <a:rPr sz="1100" b="0" i="0" dirty="0" err="1">
+                          <a:solidFill>
+                            <a:srgbClr val="1A1A1A"/>
+                          </a:solidFill>
+                          <a:latin typeface="Calibri"/>
+                        </a:rPr>
+                        <a:t>organizar</a:t>
+                      </a:r>
+                      <a:r>
+                        <a:rPr sz="1100" b="0" i="0" dirty="0">
+                          <a:solidFill>
+                            <a:srgbClr val="1A1A1A"/>
+                          </a:solidFill>
+                          <a:latin typeface="Calibri"/>
+                        </a:rPr>
+                        <a:t> a </a:t>
+                      </a:r>
+                      <a:r>
+                        <a:rPr sz="1100" b="0" i="0" dirty="0" err="1">
+                          <a:solidFill>
+                            <a:srgbClr val="1A1A1A"/>
+                          </a:solidFill>
+                          <a:latin typeface="Calibri"/>
+                        </a:rPr>
+                        <a:t>los</a:t>
+                      </a:r>
+                      <a:r>
+                        <a:rPr sz="1100" b="0" i="0" dirty="0">
+                          <a:solidFill>
+                            <a:srgbClr val="1A1A1A"/>
+                          </a:solidFill>
+                          <a:latin typeface="Calibri"/>
+                        </a:rPr>
+                        <a:t> </a:t>
+                      </a:r>
+                      <a:r>
+                        <a:rPr sz="1100" b="0" i="0" dirty="0" err="1">
+                          <a:solidFill>
+                            <a:srgbClr val="1A1A1A"/>
+                          </a:solidFill>
+                          <a:latin typeface="Calibri"/>
+                        </a:rPr>
+                        <a:t>clientes</a:t>
+                      </a:r>
+                      <a:r>
+                        <a:rPr sz="1100" b="0" i="0" dirty="0">
+                          <a:solidFill>
+                            <a:srgbClr val="1A1A1A"/>
+                          </a:solidFill>
+                          <a:latin typeface="Calibri"/>
+                        </a:rPr>
+                        <a:t>? (</a:t>
+                      </a:r>
+                      <a:r>
+                        <a:rPr sz="1100" b="0" i="0" dirty="0" err="1">
+                          <a:solidFill>
+                            <a:srgbClr val="1A1A1A"/>
+                          </a:solidFill>
+                          <a:latin typeface="Calibri"/>
+                        </a:rPr>
+                        <a:t>escalado</a:t>
+                      </a:r>
+                      <a:r>
+                        <a:rPr sz="1100" b="0" i="0" dirty="0">
+                          <a:solidFill>
+                            <a:srgbClr val="1A1A1A"/>
+                          </a:solidFill>
+                          <a:latin typeface="Calibri"/>
+                        </a:rPr>
+                        <a:t> → PCA → K-Means vs DBSCAN)</a:t>
                       </a:r>
                     </a:p>
                   </a:txBody>
@@ -7676,7 +8496,7 @@
 </p:sld>
 </file>
 
-<file path=ppt/slides/slide15.xml><?xml version="1.0" encoding="utf-8"?>
+<file path=ppt/slides/slide16.xml><?xml version="1.0" encoding="utf-8"?>
 <p:sld xmlns:a="http://schemas.openxmlformats.org/drawingml/2006/main" xmlns:r="http://schemas.openxmlformats.org/officeDocument/2006/relationships" xmlns:p="http://schemas.openxmlformats.org/presentationml/2006/main">
   <p:cSld>
     <p:bg>

</xml_diff>